<commit_message>
Update slide 2 speaker notes and chart title wording
Co-Authored-By: Claude Sonnet 5.5 <noreply@anthropic.com>
Claude-Session: https://claude.ai/code/session_01N1hDbNZrvUYuJzN9gLpZiK
</commit_message>
<xml_diff>
--- a/과제배경_수정.pptx
+++ b/과제배경_수정.pptx
@@ -629,13 +629,25 @@
           <a:p>
             <a:r>
               <a:rPr lang="ko-KR" dirty="0"/>
-              <a:t>[발표 스크립트 | 슬라이드 15 | 약 1분15초 | 누적 약 17분]</a:t>
+              <a:t>[발표 스크립트 | 슬라이드 15 | 약 1분30초 | 누적 약 17분 15초]</a:t>
             </a:r>
           </a:p>
           <a:p>
             <a:r>
               <a:rPr lang="ko-KR" dirty="0"/>
-              <a:t>뒤 설명을 위해 KV 캐시와 Prefill/Decode를 짧게 정리합니다. LLM은 다음 토큰을 만들 때 앞선 모든 토큰의 Key와 Value를 참조합니다. 이를 매번 다시 계산하지 않도록 저장해 두는 것이 KV 캐시입니다.</a:t>
+              <a:t>뒤 설명을 위해 Agent의 동작 방식과 KV 캐시, Prefill/Decode를 짧게 정리합니다.</a:t>
+            </a:r>
+          </a:p>
+          <a:p>
+            <a:r>
+              <a:rPr lang="ko-KR" dirty="0"/>
+              <a:t>먼저 왼쪽 그림입니다. Agent Controller가 사용자의 요청을 받아 여러 모델과 SW 호출을 제어합니다. 예를 들어 '개발 문서를 찾아서 읽고 코드를 수정해줘'라는 요청이 들어오면, 1단계에서는 시스템 프롬프트와 도구 정의, 사용자 요청을 합친 약 10K 토큰이 LLM에 들어가고, LLM이 Web Search를 호출해 30K 토큰의 검색 결과가 돌아옵니다. 2단계에서는 앞의 10K에 검색 결과 30K를 더한 40K 토큰이 입력되고, 코드 수정 결과 20K가 추가됩니다. 3단계에서는 60K 토큰이 입력되고 컴파일러를 수행해 결과 로그 10K가 붙습니다. 이렇게 단계가 진행될 때마다 문맥이 계속 누적됩니다. 아래 KVcache는 이 문맥에 대한 KV 캐시와 중간 기억이 계속 쌓이고 유지되는 저장 공간을 나타냅니다.</a:t>
+            </a:r>
+          </a:p>
+          <a:p>
+            <a:r>
+              <a:rPr lang="ko-KR" dirty="0"/>
+              <a:t>오른쪽은 이 과정을 KV 캐시 관점에서 풀어 본 것입니다. LLM은 다음 토큰을 만들 때 앞선 모든 토큰의 Key와 Value를 참조합니다. 이를 매번 다시 계산하지 않도록 저장해 두는 것이 KV 캐시입니다.</a:t>
             </a:r>
           </a:p>
           <a:p>
@@ -647,7 +659,7 @@
           <a:p>
             <a:r>
               <a:rPr lang="ko-KR" dirty="0"/>
-              <a:t>문제는 크기입니다. KV 캐시는 문맥 길이에 정비례해서, 70B급 모델 FP16 기준으로 4K 토큰이면 약 1.3GB, 32K면 10GB, 128K면 40GB입니다. 여기에 동시 사용자 수가 곱해지므로, 앞에서 본 HBM 한계가 바로 여기서 나옵니다.</a:t>
+              <a:t>문제는 크기입니다. KV 캐시는 문맥 길이에 정비례해서, 70B급 모델 FP16 기준으로 4K 토큰이면 약 1.3GB, 32K면 10GB, 128K면 40GB입니다. 여기에 동시 사용자 수가 곱해집니다. 왼쪽처럼 Agent의 문맥이 수십K에서 수백K로 누적되면 KV 캐시가 빠르게 커지고, 이를 장기적으로 외삽한 것이 오른쪽 아래 그래프입니다. 2030년 KV 캐시 수요가 312.5ZB로, NAND 총 공급 1.76ZB의 177배에 달합니다. 앞에서 본 용량 병목이 바로 여기서 나옵니다.</a:t>
             </a:r>
           </a:p>
         </p:txBody>
@@ -28118,7 +28130,7 @@
                   <a:prstClr val="black"/>
                 </a:solidFill>
               </a:rPr>
-              <a:t> size(‘30</a:t>
+              <a:t> 수요(‘30</a:t>
             </a:r>
             <a:r>
               <a:rPr lang="ko-KR" altLang="en-US" sz="1000" b="1" dirty="0">
@@ -28134,7 +28146,7 @@
                   <a:prstClr val="black"/>
                 </a:solidFill>
               </a:rPr>
-              <a:t>,312 ZB),</a:t>
+              <a:t>,312.5 ZB),</a:t>
             </a:r>
             <a:r>
               <a:rPr lang="ko-KR" altLang="en-US" sz="1000" b="1" dirty="0">

</xml_diff>